<commit_message>
Added K-Fold CV, Learning Curves, and ROC/AUC validation metrics and plots
</commit_message>
<xml_diff>
--- a/presentation/final_slides.pptx
+++ b/presentation/final_slides.pptx
@@ -14,6 +14,7 @@
     <p:sldId id="262" r:id="rId13"/>
     <p:sldId id="263" r:id="rId14"/>
     <p:sldId id="264" r:id="rId15"/>
+    <p:sldId id="265" r:id="rId16"/>
   </p:sldIdLst>
   <p:sldSz cx="9144000" cy="6858000" type="screen4x3"/>
   <p:notesSz cx="6858000" cy="9144000"/>
@@ -3207,6 +3208,272 @@
             <a:br/>
             <a:r>
               <a:t>Indian Institute of Computing and Technology (IICT)</a:t>
+            </a:r>
+          </a:p>
+        </p:txBody>
+      </p:sp>
+    </p:spTree>
+  </p:cSld>
+  <p:clrMapOvr>
+    <a:masterClrMapping/>
+  </p:clrMapOvr>
+</p:sld>
+</file>
+
+<file path=ppt/slides/slide10.xml><?xml version="1.0" encoding="utf-8"?>
+<p:sld xmlns:a="http://schemas.openxmlformats.org/drawingml/2006/main" xmlns:p="http://schemas.openxmlformats.org/presentationml/2006/main" xmlns:r="http://schemas.openxmlformats.org/officeDocument/2006/relationships">
+  <p:cSld>
+    <p:spTree>
+      <p:nvGrpSpPr>
+        <p:cNvPr id="1" name=""/>
+        <p:cNvGrpSpPr/>
+        <p:nvPr/>
+      </p:nvGrpSpPr>
+      <p:grpSpPr/>
+      <p:sp>
+        <p:nvSpPr>
+          <p:cNvPr id="2" name="Rectangle 1"/>
+          <p:cNvSpPr/>
+          <p:nvPr/>
+        </p:nvSpPr>
+        <p:spPr>
+          <a:xfrm>
+            <a:off x="0" y="0"/>
+            <a:ext cx="9144000" cy="1097280"/>
+          </a:xfrm>
+          <a:prstGeom prst="rect">
+            <a:avLst/>
+          </a:prstGeom>
+          <a:solidFill>
+            <a:srgbClr val="102C57"/>
+          </a:solidFill>
+          <a:ln>
+            <a:solidFill>
+              <a:srgbClr val="102C57"/>
+            </a:solidFill>
+          </a:ln>
+        </p:spPr>
+        <p:style>
+          <a:lnRef idx="1">
+            <a:schemeClr val="accent1"/>
+          </a:lnRef>
+          <a:fillRef idx="3">
+            <a:schemeClr val="accent1"/>
+          </a:fillRef>
+          <a:effectRef idx="2">
+            <a:schemeClr val="accent1"/>
+          </a:effectRef>
+          <a:fontRef idx="minor">
+            <a:schemeClr val="lt1"/>
+          </a:fontRef>
+        </p:style>
+        <p:txBody>
+          <a:bodyPr rtlCol="0" anchor="ctr"/>
+          <a:lstStyle/>
+          <a:p>
+            <a:pPr algn="ctr"/>
+          </a:p>
+        </p:txBody>
+      </p:sp>
+      <p:sp>
+        <p:nvSpPr>
+          <p:cNvPr id="3" name="TextBox 2"/>
+          <p:cNvSpPr txBox="1"/>
+          <p:nvPr/>
+        </p:nvSpPr>
+        <p:spPr>
+          <a:xfrm>
+            <a:off x="457200" y="182880"/>
+            <a:ext cx="8229600" cy="731520"/>
+          </a:xfrm>
+          <a:prstGeom prst="rect">
+            <a:avLst/>
+          </a:prstGeom>
+          <a:noFill/>
+        </p:spPr>
+        <p:txBody>
+          <a:bodyPr wrap="square">
+            <a:spAutoFit/>
+          </a:bodyPr>
+          <a:lstStyle/>
+          <a:p>
+            <a:pPr algn="l">
+              <a:defRPr sz="2800" b="1">
+                <a:solidFill>
+                  <a:srgbClr val="FFFFFF"/>
+                </a:solidFill>
+                <a:latin typeface="Arial"/>
+              </a:defRPr>
+            </a:pPr>
+            <a:r>
+              <a:t>Conclusions &amp; Future Scope</a:t>
+            </a:r>
+          </a:p>
+        </p:txBody>
+      </p:sp>
+      <p:sp>
+        <p:nvSpPr>
+          <p:cNvPr id="4" name="TextBox 3"/>
+          <p:cNvSpPr txBox="1"/>
+          <p:nvPr/>
+        </p:nvSpPr>
+        <p:spPr>
+          <a:xfrm>
+            <a:off x="457200" y="1371600"/>
+            <a:ext cx="8229600" cy="4572000"/>
+          </a:xfrm>
+          <a:prstGeom prst="rect">
+            <a:avLst/>
+          </a:prstGeom>
+          <a:noFill/>
+        </p:spPr>
+        <p:txBody>
+          <a:bodyPr wrap="square">
+            <a:spAutoFit/>
+          </a:bodyPr>
+          <a:lstStyle/>
+          <a:p>
+            <a:pPr>
+              <a:spcAft>
+                <a:spcPts val="1200"/>
+              </a:spcAft>
+              <a:defRPr sz="1800" b="1">
+                <a:solidFill>
+                  <a:srgbClr val="3C3C3C"/>
+                </a:solidFill>
+                <a:latin typeface="Arial"/>
+              </a:defRPr>
+            </a:pPr>
+            <a:r>
+              <a:t>Project Conclusions:</a:t>
+            </a:r>
+          </a:p>
+          <a:p>
+            <a:pPr lvl="1">
+              <a:spcAft>
+                <a:spcPts val="1200"/>
+              </a:spcAft>
+              <a:defRPr sz="1800" b="0">
+                <a:solidFill>
+                  <a:srgbClr val="3C3C3C"/>
+                </a:solidFill>
+                <a:latin typeface="Arial"/>
+              </a:defRPr>
+            </a:pPr>
+            <a:r>
+              <a:t>An end-to-end pipeline built completely from scratch successfully trains classifiers to detect fake news.</a:t>
+            </a:r>
+          </a:p>
+          <a:p>
+            <a:pPr lvl="1">
+              <a:spcAft>
+                <a:spcPts val="1200"/>
+              </a:spcAft>
+              <a:defRPr sz="1800" b="0">
+                <a:solidFill>
+                  <a:srgbClr val="3C3C3C"/>
+                </a:solidFill>
+                <a:latin typeface="Arial"/>
+              </a:defRPr>
+            </a:pPr>
+            <a:r>
+              <a:t>Random Forest achieves the highest accuracy of 99.68%, but Logistic Regression is more suitable for real-time web applications due to its micro-second latency.</a:t>
+            </a:r>
+          </a:p>
+          <a:p>
+            <a:pPr>
+              <a:spcAft>
+                <a:spcPts val="1200"/>
+              </a:spcAft>
+              <a:defRPr sz="1800" b="1">
+                <a:solidFill>
+                  <a:srgbClr val="3C3C3C"/>
+                </a:solidFill>
+                <a:latin typeface="Arial"/>
+              </a:defRPr>
+            </a:pPr>
+            <a:r>
+              <a:t>Limitations:</a:t>
+            </a:r>
+          </a:p>
+          <a:p>
+            <a:pPr lvl="1">
+              <a:spcAft>
+                <a:spcPts val="1200"/>
+              </a:spcAft>
+              <a:defRPr sz="1800" b="0">
+                <a:solidFill>
+                  <a:srgbClr val="3C3C3C"/>
+                </a:solidFill>
+                <a:latin typeface="Arial"/>
+              </a:defRPr>
+            </a:pPr>
+            <a:r>
+              <a:t>U.S. election context from 2016-2017: Vocabulary is heavily topic-biased and might not generalize well to other news cycles.</a:t>
+            </a:r>
+          </a:p>
+          <a:p>
+            <a:pPr lvl="1">
+              <a:spcAft>
+                <a:spcPts val="1200"/>
+              </a:spcAft>
+              <a:defRPr sz="1800" b="0">
+                <a:solidFill>
+                  <a:srgbClr val="3C3C3C"/>
+                </a:solidFill>
+                <a:latin typeface="Arial"/>
+              </a:defRPr>
+            </a:pPr>
+            <a:r>
+              <a:t>Reuters metadata tags create template dependency rather than true semantic classification.</a:t>
+            </a:r>
+          </a:p>
+          <a:p>
+            <a:pPr>
+              <a:spcAft>
+                <a:spcPts val="1200"/>
+              </a:spcAft>
+              <a:defRPr sz="1800" b="1">
+                <a:solidFill>
+                  <a:srgbClr val="3C3C3C"/>
+                </a:solidFill>
+                <a:latin typeface="Arial"/>
+              </a:defRPr>
+            </a:pPr>
+            <a:r>
+              <a:t>Future Directions:</a:t>
+            </a:r>
+          </a:p>
+          <a:p>
+            <a:pPr lvl="1">
+              <a:spcAft>
+                <a:spcPts val="1200"/>
+              </a:spcAft>
+              <a:defRPr sz="1800" b="0">
+                <a:solidFill>
+                  <a:srgbClr val="3C3C3C"/>
+                </a:solidFill>
+                <a:latin typeface="Arial"/>
+              </a:defRPr>
+            </a:pPr>
+            <a:r>
+              <a:t>Evaluate models on out-of-domain and current news feeds to test true generalizability.</a:t>
+            </a:r>
+          </a:p>
+          <a:p>
+            <a:pPr lvl="1">
+              <a:spcAft>
+                <a:spcPts val="1200"/>
+              </a:spcAft>
+              <a:defRPr sz="1800" b="0">
+                <a:solidFill>
+                  <a:srgbClr val="3C3C3C"/>
+                </a:solidFill>
+                <a:latin typeface="Arial"/>
+              </a:defRPr>
+            </a:pPr>
+            <a:r>
+              <a:t>Incorporate n-grams (bigrams/trigrams) and deep learning models to capture text context.</a:t>
             </a:r>
           </a:p>
         </p:txBody>
@@ -5688,7 +5955,7 @@
               </a:defRPr>
             </a:pPr>
             <a:r>
-              <a:t>Key Findings &amp; Trade-offs</a:t>
+              <a:t>Robust Validation: CV, Learning Curves &amp; ROC</a:t>
             </a:r>
           </a:p>
         </p:txBody>
@@ -5701,8 +5968,8 @@
         </p:nvSpPr>
         <p:spPr>
           <a:xfrm>
-            <a:off x="457200" y="1371600"/>
-            <a:ext cx="8229600" cy="4572000"/>
+            <a:off x="365760" y="1371600"/>
+            <a:ext cx="4572000" cy="4572000"/>
           </a:xfrm>
           <a:prstGeom prst="rect">
             <a:avLst/>
@@ -5727,7 +5994,7 @@
               </a:defRPr>
             </a:pPr>
             <a:r>
-              <a:t>Parametric vs. Non-Parametric Trade-offs:</a:t>
+              <a:t>Stratified 5-Fold Cross-Validation (Full Corpus):</a:t>
             </a:r>
           </a:p>
           <a:p>
@@ -5743,7 +6010,7 @@
               </a:defRPr>
             </a:pPr>
             <a:r>
-              <a:t>KNN must retain the entire training matrix in memory for distance queries; using a sparse Compressed Sparse Row (CSR) format reduces this RAM footprint to 47.30 MB, compared to 1.19 GB if stored as a dense matrix (inference latency: 6.38s).</a:t>
+              <a:t>KNN (Cosine, K=31): 87.72% ± 0.41%</a:t>
             </a:r>
           </a:p>
           <a:p>
@@ -5759,7 +6026,7 @@
               </a:defRPr>
             </a:pPr>
             <a:r>
-              <a:t>Random Forest stores 100 deep trees (~40 MB disk size), delivering top accuracy but consuming large storage.</a:t>
+              <a:t>Logistic Regression: 98.60% ± 0.06%</a:t>
             </a:r>
           </a:p>
           <a:p>
@@ -5775,7 +6042,23 @@
               </a:defRPr>
             </a:pPr>
             <a:r>
-              <a:t>Logistic Regression only stores 5,000 weight coordinates, making it extremely lightweight (&lt;100 KB) and fast (2.5ms latency).</a:t>
+              <a:t>Random Forest: 98.19% ± 0.22%</a:t>
+            </a:r>
+          </a:p>
+          <a:p>
+            <a:pPr lvl="1">
+              <a:spcAft>
+                <a:spcPts val="1200"/>
+              </a:spcAft>
+              <a:defRPr sz="1800" b="0">
+                <a:solidFill>
+                  <a:srgbClr val="3C3C3C"/>
+                </a:solidFill>
+                <a:latin typeface="Arial"/>
+              </a:defRPr>
+            </a:pPr>
+            <a:r>
+              <a:t>MLP Neural Network: 98.26% ± 0.11%</a:t>
             </a:r>
           </a:p>
           <a:p>
@@ -5791,7 +6074,7 @@
               </a:defRPr>
             </a:pPr>
             <a:r>
-              <a:t>Data Leakage: Source Tags (Reuters):</a:t>
+              <a:t>Learning Curves:</a:t>
             </a:r>
           </a:p>
           <a:p>
@@ -5807,7 +6090,23 @@
               </a:defRPr>
             </a:pPr>
             <a:r>
-              <a:t>Real articles from the ISOT dataset contain source headers (e.g., 'Reuters'). Models learn to associate these headers with legitimacy.</a:t>
+              <a:t>Clear convergence of training and validation scores indicates no overfitting.</a:t>
+            </a:r>
+          </a:p>
+          <a:p>
+            <a:pPr>
+              <a:spcAft>
+                <a:spcPts val="1200"/>
+              </a:spcAft>
+              <a:defRPr sz="1800" b="1">
+                <a:solidFill>
+                  <a:srgbClr val="3C3C3C"/>
+                </a:solidFill>
+                <a:latin typeface="Arial"/>
+              </a:defRPr>
+            </a:pPr>
+            <a:r>
+              <a:t>ROC/AUC Analysis (Test Set):</a:t>
             </a:r>
           </a:p>
           <a:p>
@@ -5823,11 +6122,75 @@
               </a:defRPr>
             </a:pPr>
             <a:r>
-              <a:t>Stripping the token 'reuters' drops accuracy by 1.5%, demonstrating that the classifier relies partly on textual metadata rather than semantic content.</a:t>
-            </a:r>
-          </a:p>
-        </p:txBody>
-      </p:sp>
+              <a:t>Logistic Regression (0.9987 AUC), Random Forest (0.9985 AUC)</a:t>
+            </a:r>
+          </a:p>
+          <a:p>
+            <a:pPr lvl="1">
+              <a:spcAft>
+                <a:spcPts val="1200"/>
+              </a:spcAft>
+              <a:defRPr sz="1800" b="0">
+                <a:solidFill>
+                  <a:srgbClr val="3C3C3C"/>
+                </a:solidFill>
+                <a:latin typeface="Arial"/>
+              </a:defRPr>
+            </a:pPr>
+            <a:r>
+              <a:t>MLP Neural Net (0.9983 AUC), KNN (0.9610 AUC)</a:t>
+            </a:r>
+          </a:p>
+        </p:txBody>
+      </p:sp>
+      <p:pic>
+        <p:nvPicPr>
+          <p:cNvPr id="5" name="Picture 4" descr="learning_curves.png"/>
+          <p:cNvPicPr>
+            <a:picLocks noChangeAspect="1"/>
+          </p:cNvPicPr>
+          <p:nvPr/>
+        </p:nvPicPr>
+        <p:blipFill>
+          <a:blip r:embed="rId2"/>
+          <a:stretch>
+            <a:fillRect/>
+          </a:stretch>
+        </p:blipFill>
+        <p:spPr>
+          <a:xfrm>
+            <a:off x="5120640" y="1371600"/>
+            <a:ext cx="3474720" cy="2377440"/>
+          </a:xfrm>
+          <a:prstGeom prst="rect">
+            <a:avLst/>
+          </a:prstGeom>
+        </p:spPr>
+      </p:pic>
+      <p:pic>
+        <p:nvPicPr>
+          <p:cNvPr id="6" name="Picture 5" descr="roc_curves.png"/>
+          <p:cNvPicPr>
+            <a:picLocks noChangeAspect="1"/>
+          </p:cNvPicPr>
+          <p:nvPr/>
+        </p:nvPicPr>
+        <p:blipFill>
+          <a:blip r:embed="rId3"/>
+          <a:stretch>
+            <a:fillRect/>
+          </a:stretch>
+        </p:blipFill>
+        <p:spPr>
+          <a:xfrm>
+            <a:off x="5120640" y="3931920"/>
+            <a:ext cx="3474720" cy="2377440"/>
+          </a:xfrm>
+          <a:prstGeom prst="rect">
+            <a:avLst/>
+          </a:prstGeom>
+        </p:spPr>
+      </p:pic>
     </p:spTree>
   </p:cSld>
   <p:clrMapOvr>
@@ -5922,7 +6285,7 @@
               </a:defRPr>
             </a:pPr>
             <a:r>
-              <a:t>Conclusions &amp; Future Scope</a:t>
+              <a:t>Key Findings &amp; Trade-offs</a:t>
             </a:r>
           </a:p>
         </p:txBody>
@@ -5961,7 +6324,7 @@
               </a:defRPr>
             </a:pPr>
             <a:r>
-              <a:t>Project Conclusions:</a:t>
+              <a:t>Parametric vs. Non-Parametric Trade-offs:</a:t>
             </a:r>
           </a:p>
           <a:p>
@@ -5977,7 +6340,7 @@
               </a:defRPr>
             </a:pPr>
             <a:r>
-              <a:t>An end-to-end pipeline built completely from scratch successfully trains classifiers to detect fake news.</a:t>
+              <a:t>KNN must retain the entire training matrix in memory for distance queries; using a sparse Compressed Sparse Row (CSR) format reduces this RAM footprint to 47.30 MB, compared to 1.19 GB if stored as a dense matrix (inference latency: 6.38s).</a:t>
             </a:r>
           </a:p>
           <a:p>
@@ -5993,7 +6356,23 @@
               </a:defRPr>
             </a:pPr>
             <a:r>
-              <a:t>Random Forest achieves the highest accuracy of 99.68%, but Logistic Regression is more suitable for real-time web applications due to its micro-second latency.</a:t>
+              <a:t>Random Forest stores 100 deep trees (~40 MB disk size), delivering top accuracy but consuming large storage.</a:t>
+            </a:r>
+          </a:p>
+          <a:p>
+            <a:pPr lvl="1">
+              <a:spcAft>
+                <a:spcPts val="1200"/>
+              </a:spcAft>
+              <a:defRPr sz="1800" b="0">
+                <a:solidFill>
+                  <a:srgbClr val="3C3C3C"/>
+                </a:solidFill>
+                <a:latin typeface="Arial"/>
+              </a:defRPr>
+            </a:pPr>
+            <a:r>
+              <a:t>Logistic Regression only stores 5,000 weight coordinates, making it extremely lightweight (&lt;100 KB) and fast (2.5ms latency).</a:t>
             </a:r>
           </a:p>
           <a:p>
@@ -6009,7 +6388,7 @@
               </a:defRPr>
             </a:pPr>
             <a:r>
-              <a:t>Limitations:</a:t>
+              <a:t>Data Leakage: Source Tags (Reuters):</a:t>
             </a:r>
           </a:p>
           <a:p>
@@ -6025,7 +6404,7 @@
               </a:defRPr>
             </a:pPr>
             <a:r>
-              <a:t>U.S. election context from 2016-2017: Vocabulary is heavily topic-biased and might not generalize well to other news cycles.</a:t>
+              <a:t>Real articles from the ISOT dataset contain source headers (e.g., 'Reuters'). Models learn to associate these headers with legitimacy.</a:t>
             </a:r>
           </a:p>
           <a:p>
@@ -6041,55 +6420,7 @@
               </a:defRPr>
             </a:pPr>
             <a:r>
-              <a:t>Reuters metadata tags create template dependency rather than true semantic classification.</a:t>
-            </a:r>
-          </a:p>
-          <a:p>
-            <a:pPr>
-              <a:spcAft>
-                <a:spcPts val="1200"/>
-              </a:spcAft>
-              <a:defRPr sz="1800" b="1">
-                <a:solidFill>
-                  <a:srgbClr val="3C3C3C"/>
-                </a:solidFill>
-                <a:latin typeface="Arial"/>
-              </a:defRPr>
-            </a:pPr>
-            <a:r>
-              <a:t>Future Directions:</a:t>
-            </a:r>
-          </a:p>
-          <a:p>
-            <a:pPr lvl="1">
-              <a:spcAft>
-                <a:spcPts val="1200"/>
-              </a:spcAft>
-              <a:defRPr sz="1800" b="0">
-                <a:solidFill>
-                  <a:srgbClr val="3C3C3C"/>
-                </a:solidFill>
-                <a:latin typeface="Arial"/>
-              </a:defRPr>
-            </a:pPr>
-            <a:r>
-              <a:t>Evaluate models on out-of-domain and current news feeds to test true generalizability.</a:t>
-            </a:r>
-          </a:p>
-          <a:p>
-            <a:pPr lvl="1">
-              <a:spcAft>
-                <a:spcPts val="1200"/>
-              </a:spcAft>
-              <a:defRPr sz="1800" b="0">
-                <a:solidFill>
-                  <a:srgbClr val="3C3C3C"/>
-                </a:solidFill>
-                <a:latin typeface="Arial"/>
-              </a:defRPr>
-            </a:pPr>
-            <a:r>
-              <a:t>Incorporate n-grams (bigrams/trigrams) and deep learning models to capture text context.</a:t>
+              <a:t>Stripping the token 'reuters' drops accuracy by 1.5%, demonstrating that the classifier relies partly on textual metadata rather than semantic content.</a:t>
             </a:r>
           </a:p>
         </p:txBody>

</xml_diff>